<commit_message>
Publish three-objective Thailand water-storage research dashboard
</commit_message>
<xml_diff>
--- a/downloads/Thailand_Three_Objectives_Farzeen_Khanal.pptx
+++ b/downloads/Thailand_Three_Objectives_Farzeen_Khanal.pptx
@@ -4784,7 +4784,7 @@
               </a:defRPr>
             </a:pPr>
             <a:r>
-              <a:t>Farzeen Khanal</a:t>
+              <a:t>Farzeen Khan</a:t>
             </a:r>
           </a:p>
         </p:txBody>
@@ -5216,7 +5216,7 @@
               </a:defRPr>
             </a:pPr>
             <a:r>
-              <a:t>Farzeen Khanal • AIT • 24 October 2026</a:t>
+              <a:t>Farzeen Khan • AIT • 24 October 2026</a:t>
             </a:r>
           </a:p>
         </p:txBody>
@@ -5677,7 +5677,7 @@
               </a:defRPr>
             </a:pPr>
             <a:r>
-              <a:t>Farzeen Khanal • AIT • 24 October 2026</a:t>
+              <a:t>Farzeen Khan • AIT • 24 October 2026</a:t>
             </a:r>
           </a:p>
         </p:txBody>
@@ -6166,7 +6166,7 @@
               </a:defRPr>
             </a:pPr>
             <a:r>
-              <a:t>Farzeen Khanal • AIT • 24 October 2026</a:t>
+              <a:t>Farzeen Khan • AIT • 24 October 2026</a:t>
             </a:r>
           </a:p>
         </p:txBody>
@@ -6655,7 +6655,7 @@
               </a:defRPr>
             </a:pPr>
             <a:r>
-              <a:t>Farzeen Khanal • AIT • 24 October 2026</a:t>
+              <a:t>Farzeen Khan • AIT • 24 October 2026</a:t>
             </a:r>
           </a:p>
         </p:txBody>
@@ -8175,7 +8175,7 @@
               </a:defRPr>
             </a:pPr>
             <a:r>
-              <a:t>Farzeen Khanal • AIT • 24 October 2026</a:t>
+              <a:t>Farzeen Khan • AIT • 24 October 2026</a:t>
             </a:r>
           </a:p>
         </p:txBody>
@@ -8636,7 +8636,7 @@
               </a:defRPr>
             </a:pPr>
             <a:r>
-              <a:t>Farzeen Khanal • AIT • 24 October 2026</a:t>
+              <a:t>Farzeen Khan • AIT • 24 October 2026</a:t>
             </a:r>
           </a:p>
         </p:txBody>
@@ -10039,7 +10039,7 @@
               </a:defRPr>
             </a:pPr>
             <a:r>
-              <a:t>Farzeen Khanal • AIT • 24 October 2026</a:t>
+              <a:t>Farzeen Khan • AIT • 24 October 2026</a:t>
             </a:r>
           </a:p>
         </p:txBody>
@@ -10932,7 +10932,7 @@
               </a:defRPr>
             </a:pPr>
             <a:r>
-              <a:t>Farzeen Khanal • AIT • 24 October 2026</a:t>
+              <a:t>Farzeen Khan • AIT • 24 October 2026</a:t>
             </a:r>
           </a:p>
         </p:txBody>
@@ -11825,7 +11825,7 @@
               </a:defRPr>
             </a:pPr>
             <a:r>
-              <a:t>Farzeen Khanal • AIT • 24 October 2026</a:t>
+              <a:t>Farzeen Khan • AIT • 24 October 2026</a:t>
             </a:r>
           </a:p>
         </p:txBody>
@@ -12718,7 +12718,7 @@
               </a:defRPr>
             </a:pPr>
             <a:r>
-              <a:t>Farzeen Khanal • AIT • 24 October 2026</a:t>
+              <a:t>Farzeen Khan • AIT • 24 October 2026</a:t>
             </a:r>
           </a:p>
         </p:txBody>
@@ -13611,7 +13611,7 @@
               </a:defRPr>
             </a:pPr>
             <a:r>
-              <a:t>Farzeen Khanal • AIT • 24 October 2026</a:t>
+              <a:t>Farzeen Khan • AIT • 24 October 2026</a:t>
             </a:r>
           </a:p>
         </p:txBody>
@@ -14504,7 +14504,7 @@
               </a:defRPr>
             </a:pPr>
             <a:r>
-              <a:t>Farzeen Khanal • AIT • 24 October 2026</a:t>
+              <a:t>Farzeen Khan • AIT • 24 October 2026</a:t>
             </a:r>
           </a:p>
         </p:txBody>
@@ -15397,7 +15397,7 @@
               </a:defRPr>
             </a:pPr>
             <a:r>
-              <a:t>Farzeen Khanal • AIT • 24 October 2026</a:t>
+              <a:t>Farzeen Khan • AIT • 24 October 2026</a:t>
             </a:r>
           </a:p>
         </p:txBody>
@@ -15858,7 +15858,7 @@
               </a:defRPr>
             </a:pPr>
             <a:r>
-              <a:t>Farzeen Khanal • AIT • 24 October 2026</a:t>
+              <a:t>Farzeen Khan • AIT • 24 October 2026</a:t>
             </a:r>
           </a:p>
         </p:txBody>
@@ -16829,7 +16829,7 @@
               </a:defRPr>
             </a:pPr>
             <a:r>
-              <a:t>Farzeen Khanal • AIT • 24 October 2026</a:t>
+              <a:t>Farzeen Khan • AIT • 24 October 2026</a:t>
             </a:r>
           </a:p>
         </p:txBody>
@@ -18117,7 +18117,7 @@
               </a:defRPr>
             </a:pPr>
             <a:r>
-              <a:t>Farzeen Khanal • AIT • 24 October 2026</a:t>
+              <a:t>Farzeen Khan • AIT • 24 October 2026</a:t>
             </a:r>
           </a:p>
         </p:txBody>

</xml_diff>